<commit_message>
minimal changes to docs and plots
</commit_message>
<xml_diff>
--- a/docs/mimic/mimic-feasibility-analysis.pptx
+++ b/docs/mimic/mimic-feasibility-analysis.pptx
@@ -232,7 +232,7 @@
           <a:p>
             <a:fld id="{1095136B-D240-4AC1-860D-A53BD70B9DD0}" type="datetimeFigureOut">
               <a:rPr lang="LID4096" smtClean="0"/>
-              <a:t>04/15/2026</a:t>
+              <a:t>06/18/2026</a:t>
             </a:fld>
             <a:endParaRPr lang="LID4096"/>
           </a:p>
@@ -679,7 +679,7 @@
           <a:p>
             <a:fld id="{7946C467-44DF-404A-AD8D-BD7FC61F89E0}" type="datetime1">
               <a:rPr lang="en-US" smtClean="0"/>
-              <a:t>4/15/2026</a:t>
+              <a:t>6/18/2026</a:t>
             </a:fld>
             <a:endParaRPr lang="en-US"/>
           </a:p>
@@ -847,7 +847,7 @@
           <a:p>
             <a:fld id="{F7DE8645-AF42-4890-A560-4B70522C4AFC}" type="datetime1">
               <a:rPr lang="en-US" smtClean="0"/>
-              <a:t>4/15/2026</a:t>
+              <a:t>6/18/2026</a:t>
             </a:fld>
             <a:endParaRPr lang="en-US"/>
           </a:p>
@@ -1025,7 +1025,7 @@
           <a:p>
             <a:fld id="{F2A694C5-6E2F-4E41-B8EF-647314903EED}" type="datetime1">
               <a:rPr lang="en-US" smtClean="0"/>
-              <a:t>4/15/2026</a:t>
+              <a:t>6/18/2026</a:t>
             </a:fld>
             <a:endParaRPr lang="en-US"/>
           </a:p>
@@ -1193,7 +1193,7 @@
           <a:p>
             <a:fld id="{3DF8CFE6-D184-487A-ACD8-A82DCF433FE4}" type="datetime1">
               <a:rPr lang="en-US" smtClean="0"/>
-              <a:t>4/15/2026</a:t>
+              <a:t>6/18/2026</a:t>
             </a:fld>
             <a:endParaRPr lang="en-US"/>
           </a:p>
@@ -1438,7 +1438,7 @@
           <a:p>
             <a:fld id="{DCCF5D13-F6BB-4CFE-9D3A-C12C7FF7146A}" type="datetime1">
               <a:rPr lang="en-US" smtClean="0"/>
-              <a:t>4/15/2026</a:t>
+              <a:t>6/18/2026</a:t>
             </a:fld>
             <a:endParaRPr lang="en-US"/>
           </a:p>
@@ -1723,7 +1723,7 @@
           <a:p>
             <a:fld id="{80C06912-22D9-4F6C-B8D3-B4D2C75C002C}" type="datetime1">
               <a:rPr lang="en-US" smtClean="0"/>
-              <a:t>4/15/2026</a:t>
+              <a:t>6/18/2026</a:t>
             </a:fld>
             <a:endParaRPr lang="en-US"/>
           </a:p>
@@ -2142,7 +2142,7 @@
           <a:p>
             <a:fld id="{9A0D3F3C-ACFC-4546-A995-7A6F4D5F2C2F}" type="datetime1">
               <a:rPr lang="en-US" smtClean="0"/>
-              <a:t>4/15/2026</a:t>
+              <a:t>6/18/2026</a:t>
             </a:fld>
             <a:endParaRPr lang="en-US"/>
           </a:p>
@@ -2259,7 +2259,7 @@
           <a:p>
             <a:fld id="{350F4C59-E9D1-4841-8245-1515E61AFD97}" type="datetime1">
               <a:rPr lang="en-US" smtClean="0"/>
-              <a:t>4/15/2026</a:t>
+              <a:t>6/18/2026</a:t>
             </a:fld>
             <a:endParaRPr lang="en-US"/>
           </a:p>
@@ -2354,7 +2354,7 @@
           <a:p>
             <a:fld id="{20FE2A83-F9D6-485C-B62C-7D807D9F4EEC}" type="datetime1">
               <a:rPr lang="en-US" smtClean="0"/>
-              <a:t>4/15/2026</a:t>
+              <a:t>6/18/2026</a:t>
             </a:fld>
             <a:endParaRPr lang="en-US"/>
           </a:p>
@@ -2634,7 +2634,7 @@
           <a:p>
             <a:fld id="{65A34C42-C467-4317-9AB6-F6377EDB2B46}" type="datetime1">
               <a:rPr lang="en-US" smtClean="0"/>
-              <a:t>4/15/2026</a:t>
+              <a:t>6/18/2026</a:t>
             </a:fld>
             <a:endParaRPr lang="en-US"/>
           </a:p>
@@ -2886,7 +2886,7 @@
           <a:p>
             <a:fld id="{7CCA7F95-4EC6-49DA-B964-0DFF9C20A579}" type="datetime1">
               <a:rPr lang="en-US" smtClean="0"/>
-              <a:t>4/15/2026</a:t>
+              <a:t>6/18/2026</a:t>
             </a:fld>
             <a:endParaRPr lang="en-US"/>
           </a:p>
@@ -3097,7 +3097,7 @@
           <a:p>
             <a:fld id="{9A8C62E3-A9B5-4551-83D8-3C193A9C17DB}" type="datetime1">
               <a:rPr lang="en-US" smtClean="0"/>
-              <a:t>4/15/2026</a:t>
+              <a:t>6/18/2026</a:t>
             </a:fld>
             <a:endParaRPr lang="en-US"/>
           </a:p>
@@ -7802,8 +7802,8 @@
           </a:p>
         </p:txBody>
       </p:sp>
-      <mc:AlternateContent xmlns:mc="http://schemas.openxmlformats.org/markup-compatibility/2006">
-        <mc:Choice xmlns:a14="http://schemas.microsoft.com/office/drawing/2010/main" Requires="a14">
+      <mc:AlternateContent xmlns:mc="http://schemas.openxmlformats.org/markup-compatibility/2006" xmlns:a14="http://schemas.microsoft.com/office/drawing/2010/main">
+        <mc:Choice Requires="a14">
           <p:graphicFrame>
             <p:nvGraphicFramePr>
               <p:cNvPr id="6" name="Table 5"/>
@@ -9002,7 +9002,7 @@
             </a:graphic>
           </p:graphicFrame>
         </mc:Choice>
-        <mc:Fallback>
+        <mc:Fallback xmlns="">
           <p:graphicFrame>
             <p:nvGraphicFramePr>
               <p:cNvPr id="6" name="Table 5"/>
@@ -18088,7 +18088,7 @@
           <p:nvPr>
             <p:extLst>
               <p:ext uri="{D42A27DB-BD31-4B8C-83A1-F6EECF244321}">
-                <p14:modId xmlns:p14="http://schemas.microsoft.com/office/powerpoint/2010/main" val="1357620072"/>
+                <p14:modId xmlns:p14="http://schemas.microsoft.com/office/powerpoint/2010/main" val="1243787948"/>
               </p:ext>
             </p:extLst>
           </p:nvPr>

</xml_diff>